<commit_message>
docs: Investor Pitch v2 FINAL — mid-market contractor + developer=sales ops edits
</commit_message>
<xml_diff>
--- a/docs/PropPlatform_Investor_Pitch_v2_02Jun2026.pptx
+++ b/docs/PropPlatform_Investor_Pitch_v2_02Jun2026.pptx
@@ -5486,7 +5486,7 @@
                 <a:ea typeface="Calibri" pitchFamily="34" charset="-122"/>
                 <a:cs typeface="Calibri" pitchFamily="34" charset="-120"/>
               </a:rPr>
-              <a:t>Broker</a:t>
+              <a:t>Broker — Sales</a:t>
             </a:r>
             <a:endParaRPr lang="en-US" sz="1300" dirty="0"/>
           </a:p>
@@ -5564,7 +5564,7 @@
                 <a:ea typeface="Arial Black" pitchFamily="34" charset="-122"/>
                 <a:cs typeface="Arial Black" pitchFamily="34" charset="-120"/>
               </a:rPr>
-              <a:t>BUILDING NOW</a:t>
+              <a:t>NOW</a:t>
             </a:r>
             <a:endParaRPr lang="en-US" sz="900" dirty="0"/>
           </a:p>
@@ -5628,7 +5628,7 @@
                 <a:ea typeface="Calibri" pitchFamily="34" charset="-122"/>
                 <a:cs typeface="Calibri" pitchFamily="34" charset="-120"/>
               </a:rPr>
-              <a:t>Builder / Developer</a:t>
+              <a:t>Broker — Leasing</a:t>
             </a:r>
             <a:endParaRPr lang="en-US" sz="1300" dirty="0"/>
           </a:p>
@@ -5667,7 +5667,7 @@
                 <a:ea typeface="Calibri" pitchFamily="34" charset="-122"/>
                 <a:cs typeface="Calibri" pitchFamily="34" charset="-120"/>
               </a:rPr>
-              <a:t>30-50</a:t>
+              <a:t>5,000+</a:t>
             </a:r>
             <a:endParaRPr lang="en-US" sz="1200" dirty="0"/>
           </a:p>
@@ -5706,7 +5706,7 @@
                 <a:ea typeface="Arial Black" pitchFamily="34" charset="-122"/>
                 <a:cs typeface="Arial Black" pitchFamily="34" charset="-120"/>
               </a:rPr>
-              <a:t>Year 2 H1</a:t>
+              <a:t>NEXT</a:t>
             </a:r>
             <a:endParaRPr lang="en-US" sz="900" dirty="0"/>
           </a:p>
@@ -5848,7 +5848,7 @@
                 <a:ea typeface="Arial Black" pitchFamily="34" charset="-122"/>
                 <a:cs typeface="Arial Black" pitchFamily="34" charset="-120"/>
               </a:rPr>
-              <a:t>Year 2 H2</a:t>
+              <a:t>LATER</a:t>
             </a:r>
             <a:endParaRPr lang="en-US" sz="900" dirty="0"/>
           </a:p>
@@ -5912,7 +5912,7 @@
                 <a:ea typeface="Calibri" pitchFamily="34" charset="-122"/>
                 <a:cs typeface="Calibri" pitchFamily="34" charset="-120"/>
               </a:rPr>
-              <a:t>Construction Planning</a:t>
+              <a:t>Facilities Mgmt</a:t>
             </a:r>
             <a:endParaRPr lang="en-US" sz="1300" dirty="0"/>
           </a:p>
@@ -5951,7 +5951,7 @@
                 <a:ea typeface="Calibri" pitchFamily="34" charset="-122"/>
                 <a:cs typeface="Calibri" pitchFamily="34" charset="-120"/>
               </a:rPr>
-              <a:t>Tens</a:t>
+              <a:t>Hundreds</a:t>
             </a:r>
             <a:endParaRPr lang="en-US" sz="1200" dirty="0"/>
           </a:p>
@@ -5990,7 +5990,7 @@
                 <a:ea typeface="Arial Black" pitchFamily="34" charset="-122"/>
                 <a:cs typeface="Arial Black" pitchFamily="34" charset="-120"/>
               </a:rPr>
-              <a:t>Year 3 H1</a:t>
+              <a:t>LATER</a:t>
             </a:r>
             <a:endParaRPr lang="en-US" sz="900" dirty="0"/>
           </a:p>
@@ -6054,7 +6054,7 @@
                 <a:ea typeface="Calibri" pitchFamily="34" charset="-122"/>
                 <a:cs typeface="Calibri" pitchFamily="34" charset="-120"/>
               </a:rPr>
-              <a:t>Facilities Management</a:t>
+              <a:t>Developer</a:t>
             </a:r>
             <a:endParaRPr lang="en-US" sz="1300" dirty="0"/>
           </a:p>
@@ -6093,7 +6093,7 @@
                 <a:ea typeface="Calibri" pitchFamily="34" charset="-122"/>
                 <a:cs typeface="Calibri" pitchFamily="34" charset="-120"/>
               </a:rPr>
-              <a:t>Hundreds</a:t>
+              <a:t>30-50</a:t>
             </a:r>
             <a:endParaRPr lang="en-US" sz="1200" dirty="0"/>
           </a:p>
@@ -6132,7 +6132,7 @@
                 <a:ea typeface="Arial Black" pitchFamily="34" charset="-122"/>
                 <a:cs typeface="Arial Black" pitchFamily="34" charset="-120"/>
               </a:rPr>
-              <a:t>Year 3 H2</a:t>
+              <a:t>LAST</a:t>
             </a:r>
             <a:endParaRPr lang="en-US" sz="900" dirty="0"/>
           </a:p>
@@ -6211,7 +6211,7 @@
                 <a:ea typeface="Calibri" pitchFamily="34" charset="-122"/>
                 <a:cs typeface="Calibri" pitchFamily="34" charset="-120"/>
               </a:rPr>
-              <a:t xml:space="preserve">We ship Broker Edition first, prove it, then add segments one at a time over 2-3 years. </a:t>
+              <a:t xml:space="preserve">We ship Broker Sales first, prove it, then add segments one at a time. </a:t>
             </a:r>
             <a:pPr indent="0" marL="0">
               <a:lnSpc>
@@ -6228,7 +6228,7 @@
                 <a:ea typeface="Calibri" pitchFamily="34" charset="-122"/>
                 <a:cs typeface="Calibri" pitchFamily="34" charset="-120"/>
               </a:rPr>
-              <a:t>Same platform. Each release expands the market.</a:t>
+              <a:t>The broker / real-estate community is our firm first target. Sequence after that may shift with market dynamics.</a:t>
             </a:r>
             <a:endParaRPr lang="en-US" sz="1400" dirty="0"/>
           </a:p>
@@ -7577,7 +7577,7 @@
                 <a:ea typeface="Calibri" pitchFamily="34" charset="-122"/>
                 <a:cs typeface="Calibri" pitchFamily="34" charset="-120"/>
               </a:rPr>
-              <a:t>Broker Edition v1</a:t>
+              <a:t>Broker Sales v1</a:t>
             </a:r>
             <a:endParaRPr lang="en-US" sz="1300" dirty="0"/>
           </a:p>
@@ -7678,7 +7678,7 @@
                 <a:ea typeface="Arial Black" pitchFamily="34" charset="-122"/>
                 <a:cs typeface="Arial Black" pitchFamily="34" charset="-120"/>
               </a:rPr>
-              <a:t>Year 2 H1</a:t>
+              <a:t>NEXT</a:t>
             </a:r>
             <a:endParaRPr lang="en-US" sz="1000" dirty="0"/>
           </a:p>
@@ -7766,7 +7766,7 @@
                 <a:ea typeface="Calibri" pitchFamily="34" charset="-122"/>
                 <a:cs typeface="Calibri" pitchFamily="34" charset="-120"/>
               </a:rPr>
-              <a:t>Builder Edition</a:t>
+              <a:t>Broker Leasing</a:t>
             </a:r>
             <a:endParaRPr lang="en-US" sz="1300" dirty="0"/>
           </a:p>
@@ -7808,7 +7808,7 @@
                 <a:ea typeface="Calibri" pitchFamily="34" charset="-122"/>
                 <a:cs typeface="Calibri" pitchFamily="34" charset="-120"/>
               </a:rPr>
-              <a:t>New segment.</a:t>
+              <a:t>Leasing workflows.</a:t>
             </a:r>
             <a:endParaRPr lang="en-US" sz="1000" dirty="0"/>
           </a:p>
@@ -7867,7 +7867,7 @@
                 <a:ea typeface="Arial Black" pitchFamily="34" charset="-122"/>
                 <a:cs typeface="Arial Black" pitchFamily="34" charset="-120"/>
               </a:rPr>
-              <a:t>Year 2 H2</a:t>
+              <a:t>LATER</a:t>
             </a:r>
             <a:endParaRPr lang="en-US" sz="1000" dirty="0"/>
           </a:p>
@@ -7955,7 +7955,7 @@
                 <a:ea typeface="Calibri" pitchFamily="34" charset="-122"/>
                 <a:cs typeface="Calibri" pitchFamily="34" charset="-120"/>
               </a:rPr>
-              <a:t>Contractor Edition</a:t>
+              <a:t>Contractor</a:t>
             </a:r>
             <a:endParaRPr lang="en-US" sz="1300" dirty="0"/>
           </a:p>
@@ -8056,7 +8056,7 @@
                 <a:ea typeface="Arial Black" pitchFamily="34" charset="-122"/>
                 <a:cs typeface="Arial Black" pitchFamily="34" charset="-120"/>
               </a:rPr>
-              <a:t>Year 3 H1</a:t>
+              <a:t>LATER</a:t>
             </a:r>
             <a:endParaRPr lang="en-US" sz="1000" dirty="0"/>
           </a:p>
@@ -8144,7 +8144,7 @@
                 <a:ea typeface="Calibri" pitchFamily="34" charset="-122"/>
                 <a:cs typeface="Calibri" pitchFamily="34" charset="-120"/>
               </a:rPr>
-              <a:t>Planning Edition</a:t>
+              <a:t>Facilities Mgmt</a:t>
             </a:r>
             <a:endParaRPr lang="en-US" sz="1300" dirty="0"/>
           </a:p>
@@ -8186,7 +8186,7 @@
                 <a:ea typeface="Calibri" pitchFamily="34" charset="-122"/>
                 <a:cs typeface="Calibri" pitchFamily="34" charset="-120"/>
               </a:rPr>
-              <a:t>Land + master plans.</a:t>
+              <a:t>Post-handover.</a:t>
             </a:r>
             <a:endParaRPr lang="en-US" sz="1000" dirty="0"/>
           </a:p>
@@ -8206,7 +8206,7 @@
                 <a:ea typeface="Calibri" pitchFamily="34" charset="-122"/>
                 <a:cs typeface="Calibri" pitchFamily="34" charset="-120"/>
               </a:rPr>
-              <a:t>Regulatory.</a:t>
+              <a:t>Tenant + maintenance.</a:t>
             </a:r>
             <a:endParaRPr lang="en-US" sz="1000" dirty="0"/>
           </a:p>
@@ -8245,7 +8245,7 @@
                 <a:ea typeface="Arial Black" pitchFamily="34" charset="-122"/>
                 <a:cs typeface="Arial Black" pitchFamily="34" charset="-120"/>
               </a:rPr>
-              <a:t>Year 3 H2</a:t>
+              <a:t>LAST</a:t>
             </a:r>
             <a:endParaRPr lang="en-US" sz="1000" dirty="0"/>
           </a:p>
@@ -8333,7 +8333,7 @@
                 <a:ea typeface="Calibri" pitchFamily="34" charset="-122"/>
                 <a:cs typeface="Calibri" pitchFamily="34" charset="-120"/>
               </a:rPr>
-              <a:t>Facilities Mgmt</a:t>
+              <a:t>Developer</a:t>
             </a:r>
             <a:endParaRPr lang="en-US" sz="1300" dirty="0"/>
           </a:p>
@@ -8375,7 +8375,7 @@
                 <a:ea typeface="Calibri" pitchFamily="34" charset="-122"/>
                 <a:cs typeface="Calibri" pitchFamily="34" charset="-120"/>
               </a:rPr>
-              <a:t>Post-handover.</a:t>
+              <a:t>Builder + developer ops.</a:t>
             </a:r>
             <a:endParaRPr lang="en-US" sz="1000" dirty="0"/>
           </a:p>
@@ -8395,7 +8395,7 @@
                 <a:ea typeface="Calibri" pitchFamily="34" charset="-122"/>
                 <a:cs typeface="Calibri" pitchFamily="34" charset="-120"/>
               </a:rPr>
-              <a:t>Tenant + maintenance.</a:t>
+              <a:t>Hardest to convert.</a:t>
             </a:r>
             <a:endParaRPr lang="en-US" sz="1000" dirty="0"/>
           </a:p>

</xml_diff>